<commit_message>
Revise AX direction for quality value creation and Agentic AI
</commit_message>
<xml_diff>
--- a/AX_팀추진방향_2026-10-27/팀_AX_추진방향.pptx
+++ b/AX_팀추진방향_2026-10-27/팀_AX_추진방향.pptx
@@ -508,37 +508,43 @@
           <a:p/>
           <a:p>
             <a:r>
-              <a:t>2026년에는 여러분의 관심과 참여 덕분에 우리 팀에 AI 활용 문화가 성공적으로 자리 잡았습니다. 새로운 방식을 받아들이고 실제 업무에 활용해 주신 노력에 감사드립니다. 그 과정에서 쌓은 경험과 노하우는 우리 팀이 다음 단계로 나아갈 수 있는 중요한 기반입니다.</a:t>
+              <a:t>2026년에는 여러분의 관심과 참여 덕분에 AI 활용 문화가 성공적으로 자리 잡고, 앞으로 나아갈 기반도 마련됐습니다. 함께 변화를 만들어 주신 여러분께 감사드립니다.</a:t>
             </a:r>
           </a:p>
           <a:p/>
           <a:p>
             <a:r>
-              <a:t>2027년에는 이 문화를 바탕으로 품질팀 전체 업무로 개선의 폭을 넓혀갑시다. 각자의 업무는 물론, 담당자 사이에 연결되는 과정까지 함께 살펴보고 팀 전체의 일하는 방식을 발전시키고자 합니다.</a:t>
+              <a:t>2027년에는 이 기반 위에서 AI 활용을 품질팀 전체 업무로 확대하고자 합니다. 우리의 개선이 업무 효율과 품질 수준을 높이고, 실제 경영효과까지 이어지도록 도전의 폭을 넓혀갑시다.</a:t>
             </a:r>
           </a:p>
           <a:p/>
           <a:p>
             <a:r>
-              <a:t>품질 업무는 여러 담당자의 정보와 판단이 이어져 하나의 결과를 만드는 일입니다. 업무 사이의 연결까지 개선 범위를 넓히면, 올해 쌓은 AI 활용 경험을 팀 전체의 업무 효율과 품질 향상으로 이어갈 수 있습니다.</a:t>
+              <a:t>첫 번째 방향은 E2E 프로세스 재설계입니다. 업무의 시작부터 최종 결과까지 연결해서 바라보고, 기존 업무를 AI 중심으로 전환하겠습니다. 개별 업무와 담당자 사이의 연결까지 함께 발전시켜, 최종적인 경영효과를 만들어가자는 의미입니다.</a:t>
             </a:r>
           </a:p>
           <a:p/>
           <a:p>
             <a:r>
-              <a:t>그 과정에서 AI의 가능성과 우리가 쌓아 온 품질 전문성을 함께 살려가고자 합니다. 반복적인 일에 드는 부담을 덜고, 원인을 깊이 이해하고 문제를 예방하며 더 나은 판단을 내리는 데 우리의 역량을 집중할 수 있도록 하겠습니다.</a:t>
+              <a:t>두 번째는 품질 전문성 강화입니다. AI로 반복 업무의 부담을 줄이고, 우리는 품질 판단과 예방, 해결에 더 집중하고자 합니다. 현장에서 쌓아 온 경험과 전문성이 더 큰 가치를 발휘할 수 있도록 나아갑시다.</a:t>
             </a:r>
           </a:p>
           <a:p/>
           <a:p>
             <a:r>
-              <a:t>또한 각자의 좋은 시도와 경험이 동료에게도 도움이 되고, 함께 쌓은 경험이 새로운 개선으로 이어지는 팀을 만들고 싶습니다. 이런 변화가 품질팀 전체의 일하는 방식에 자연스럽게 자리 잡는 것이 우리가 지향하는 방향입니다.</a:t>
+              <a:t>세 번째는 품질 가치 창출입니다. AI를 활용한 새로운 방식의 이상 검출로 문제를 더 일찍 발견하고 예방할 가능성을 넓혀가겠습니다. 이를 통해 고객 Claim Zero라는 목표에 다가가는 것이 우리의 포부입니다.</a:t>
             </a:r>
           </a:p>
           <a:p/>
           <a:p>
             <a:r>
-              <a:t>저도 업무 간 조정과 필요한 지원을 챙기겠습니다. 올해 함께 만들어 온 AI 활용 문화를 발판으로, 내년에는 품질팀 전체가 변화를 체감할 수 있도록 함께 개선의 폭을 넓혀갑시다.</a:t>
+              <a:t>궁극적으로는 품질팀 전 업무를 AI가 실행하는 Agentic AI 운영 체제로 전환하는 방향을 지향하겠습니다. 그 과정에서 우리의 품질 전문성과 판단은 더욱 중요해질 것입니다.</a:t>
+            </a:r>
+          </a:p>
+          <a:p/>
+          <a:p>
+            <a:r>
+              <a:t>저도 필요한 지원을 함께 챙기겠습니다. 올해 함께 만든 기반을 발판으로, 내년에는 품질팀 전체와 고객이 체감하는 변화를 만들어 갑시다.</a:t>
             </a:r>
           </a:p>
           <a:p/>
@@ -3619,7 +3625,7 @@
         <p:spPr>
           <a:xfrm>
             <a:off x="585216" y="850392"/>
-            <a:ext cx="6521279" cy="793699"/>
+            <a:ext cx="5654921" cy="793699"/>
           </a:xfrm>
           <a:prstGeom prst="rect">
             <a:avLst/>
@@ -3652,7 +3658,7 @@
                 <a:ea typeface="Pretendard SemiBold"/>
                 <a:cs typeface="Pretendard SemiBold"/>
               </a:rPr>
-              <a:t>’26년에 정착한 AI 활용 문화를, </a:t>
+              <a:t>’26년 AI 활용 기반 마련 → </a:t>
             </a:r>
           </a:p>
         </p:txBody>
@@ -3665,8 +3671,8 @@
         </p:nvSpPr>
         <p:spPr>
           <a:xfrm>
-            <a:off x="6996767" y="850392"/>
-            <a:ext cx="5765934" cy="793699"/>
+            <a:off x="6130409" y="850392"/>
+            <a:ext cx="7440144" cy="793699"/>
           </a:xfrm>
           <a:prstGeom prst="rect">
             <a:avLst/>
@@ -3699,7 +3705,7 @@
                 <a:ea typeface="Pretendard SemiBold"/>
                 <a:cs typeface="Pretendard SemiBold"/>
               </a:rPr>
-              <a:t>’27년 품질팀 전체의 변화로.</a:t>
+              <a:t>’27년 전 영역 확산 및 품질 가치 창출</a:t>
             </a:r>
           </a:p>
         </p:txBody>
@@ -4399,7 +4405,7 @@
                 <a:ea typeface="Pretendard SemiBold"/>
                 <a:cs typeface="Pretendard SemiBold"/>
               </a:rPr>
-              <a:t>품질팀 전체 업무로 개선 확대</a:t>
+              <a:t>품질팀 전체 업무 대상 AI 활용</a:t>
             </a:r>
           </a:p>
         </p:txBody>
@@ -4413,7 +4419,7 @@
         <p:spPr>
           <a:xfrm>
             <a:off x="5669280" y="3739896"/>
-            <a:ext cx="491132" cy="538581"/>
+            <a:ext cx="417837" cy="538581"/>
           </a:xfrm>
           <a:prstGeom prst="rect">
             <a:avLst/>
@@ -4446,7 +4452,7 @@
                 <a:ea typeface="Pretendard SemiBold"/>
                 <a:cs typeface="Pretendard SemiBold"/>
               </a:rPr>
-              <a:t>01</a:t>
+              <a:t>①</a:t>
             </a:r>
           </a:p>
         </p:txBody>
@@ -4493,7 +4499,7 @@
                 <a:ea typeface="Pretendard SemiBold"/>
                 <a:cs typeface="Pretendard SemiBold"/>
               </a:rPr>
-              <a:t>업무의 연결</a:t>
+              <a:t>E2E 프로세스 재설계</a:t>
             </a:r>
           </a:p>
         </p:txBody>
@@ -4540,7 +4546,7 @@
                 <a:ea typeface="Pretendard"/>
                 <a:cs typeface="Pretendard"/>
               </a:rPr>
-              <a:t>전체 흐름을 함께 개선해</a:t>
+              <a:t>기존 업무를 AI 전환</a:t>
             </a:r>
           </a:p>
         </p:txBody>
@@ -4587,7 +4593,7 @@
                 <a:ea typeface="Pretendard"/>
                 <a:cs typeface="Pretendard"/>
               </a:rPr>
-              <a:t>팀의 효율과 품질을 높입니다</a:t>
+              <a:t>→ 최종 경영효과까지 연결</a:t>
             </a:r>
           </a:p>
         </p:txBody>
@@ -4601,7 +4607,7 @@
         <p:spPr>
           <a:xfrm>
             <a:off x="8412480" y="3739896"/>
-            <a:ext cx="541031" cy="538581"/>
+            <a:ext cx="417837" cy="538581"/>
           </a:xfrm>
           <a:prstGeom prst="rect">
             <a:avLst/>
@@ -4634,7 +4640,7 @@
                 <a:ea typeface="Pretendard SemiBold"/>
                 <a:cs typeface="Pretendard SemiBold"/>
               </a:rPr>
-              <a:t>02</a:t>
+              <a:t>②</a:t>
             </a:r>
           </a:p>
         </p:txBody>
@@ -4681,7 +4687,7 @@
                 <a:ea typeface="Pretendard SemiBold"/>
                 <a:cs typeface="Pretendard SemiBold"/>
               </a:rPr>
-              <a:t>품질 전문성</a:t>
+              <a:t>품질 전문성 강화</a:t>
             </a:r>
           </a:p>
         </p:txBody>
@@ -4728,7 +4734,7 @@
                 <a:ea typeface="Pretendard"/>
                 <a:cs typeface="Pretendard"/>
               </a:rPr>
-              <a:t>AI로 반복 업무 부담을 덜고</a:t>
+              <a:t>AI로 반복 업무 감소</a:t>
             </a:r>
           </a:p>
         </p:txBody>
@@ -4775,7 +4781,7 @@
                 <a:ea typeface="Pretendard"/>
                 <a:cs typeface="Pretendard"/>
               </a:rPr>
-              <a:t>판단·예방·해결에 집중합니다</a:t>
+              <a:t>→ 품질 판단·예방·해결에 집중</a:t>
             </a:r>
           </a:p>
         </p:txBody>
@@ -4789,7 +4795,7 @@
         <p:spPr>
           <a:xfrm>
             <a:off x="11155680" y="3739896"/>
-            <a:ext cx="551211" cy="538581"/>
+            <a:ext cx="417837" cy="538581"/>
           </a:xfrm>
           <a:prstGeom prst="rect">
             <a:avLst/>
@@ -4822,7 +4828,7 @@
                 <a:ea typeface="Pretendard SemiBold"/>
                 <a:cs typeface="Pretendard SemiBold"/>
               </a:rPr>
-              <a:t>03</a:t>
+              <a:t>③</a:t>
             </a:r>
           </a:p>
         </p:txBody>
@@ -4869,7 +4875,7 @@
                 <a:ea typeface="Pretendard SemiBold"/>
                 <a:cs typeface="Pretendard SemiBold"/>
               </a:rPr>
-              <a:t>팀 전체의 역량</a:t>
+              <a:t>품질 가치 창출</a:t>
             </a:r>
           </a:p>
         </p:txBody>
@@ -4916,7 +4922,7 @@
                 <a:ea typeface="Pretendard"/>
                 <a:cs typeface="Pretendard"/>
               </a:rPr>
-              <a:t>각자의 개선 경험을 함께 쌓아</a:t>
+              <a:t>AI 활용 신개념 이상 검출</a:t>
             </a:r>
           </a:p>
         </p:txBody>
@@ -4963,7 +4969,7 @@
                 <a:ea typeface="Pretendard"/>
                 <a:cs typeface="Pretendard"/>
               </a:rPr>
-              <a:t>새로운 개선으로 이어갑니다</a:t>
+              <a:t>→ 고객 Claim Zero 달성</a:t>
             </a:r>
           </a:p>
         </p:txBody>
@@ -5162,7 +5168,7 @@
                 <a:ea typeface="Pretendard SemiBold"/>
                 <a:cs typeface="Pretendard SemiBold"/>
               </a:rPr>
-              <a:t>업무 효율과 품질 역량이 함께 높아지는 팀</a:t>
+              <a:t>품질팀 전 업무를 AI가 실행하는 Agentic AI 운영 체제로 전환</a:t>
             </a:r>
           </a:p>
         </p:txBody>

</xml_diff>